<commit_message>
fix: now pruning correctly
</commit_message>
<xml_diff>
--- a/presentation.pptx
+++ b/presentation.pptx
@@ -5,10 +5,12 @@
     <p:sldMasterId id="2147483648" r:id="rId1"/>
   </p:sldMasterIdLst>
   <p:notesMasterIdLst>
-    <p:notesMasterId r:id="rId3"/>
+    <p:notesMasterId r:id="rId5"/>
   </p:notesMasterIdLst>
   <p:sldIdLst>
     <p:sldId id="286" r:id="rId2"/>
+    <p:sldId id="287" r:id="rId3"/>
+    <p:sldId id="288" r:id="rId4"/>
   </p:sldIdLst>
   <p:sldSz cx="12192000" cy="6858000"/>
   <p:notesSz cx="6858000" cy="9144000"/>
@@ -197,7 +199,7 @@
           <a:p>
             <a:fld id="{55456503-F03E-42AE-8BCD-24573D4B2275}" type="datetimeFigureOut">
               <a:rPr lang="fr-CH" smtClean="0"/>
-              <a:t>23.09.26</a:t>
+              <a:t>27.09.26</a:t>
             </a:fld>
             <a:endParaRPr lang="fr-CH"/>
           </a:p>
@@ -699,7 +701,7 @@
           <a:p>
             <a:fld id="{556A8663-3A33-4D99-A0DD-CF9F1D707ADE}" type="datetimeFigureOut">
               <a:rPr lang="fr-CH" smtClean="0"/>
-              <a:t>23.09.26</a:t>
+              <a:t>27.09.26</a:t>
             </a:fld>
             <a:endParaRPr lang="fr-CH"/>
           </a:p>
@@ -899,7 +901,7 @@
           <a:p>
             <a:fld id="{556A8663-3A33-4D99-A0DD-CF9F1D707ADE}" type="datetimeFigureOut">
               <a:rPr lang="fr-CH" smtClean="0"/>
-              <a:t>23.09.26</a:t>
+              <a:t>27.09.26</a:t>
             </a:fld>
             <a:endParaRPr lang="fr-CH"/>
           </a:p>
@@ -1109,7 +1111,7 @@
           <a:p>
             <a:fld id="{556A8663-3A33-4D99-A0DD-CF9F1D707ADE}" type="datetimeFigureOut">
               <a:rPr lang="fr-CH" smtClean="0"/>
-              <a:t>23.09.26</a:t>
+              <a:t>27.09.26</a:t>
             </a:fld>
             <a:endParaRPr lang="fr-CH"/>
           </a:p>
@@ -1728,7 +1730,7 @@
           <a:p>
             <a:fld id="{556A8663-3A33-4D99-A0DD-CF9F1D707ADE}" type="datetimeFigureOut">
               <a:rPr lang="fr-CH" smtClean="0"/>
-              <a:t>23.09.26</a:t>
+              <a:t>27.09.26</a:t>
             </a:fld>
             <a:endParaRPr lang="fr-CH"/>
           </a:p>
@@ -2004,7 +2006,7 @@
           <a:p>
             <a:fld id="{556A8663-3A33-4D99-A0DD-CF9F1D707ADE}" type="datetimeFigureOut">
               <a:rPr lang="fr-CH" smtClean="0"/>
-              <a:t>23.09.26</a:t>
+              <a:t>27.09.26</a:t>
             </a:fld>
             <a:endParaRPr lang="fr-CH"/>
           </a:p>
@@ -2272,7 +2274,7 @@
           <a:p>
             <a:fld id="{556A8663-3A33-4D99-A0DD-CF9F1D707ADE}" type="datetimeFigureOut">
               <a:rPr lang="fr-CH" smtClean="0"/>
-              <a:t>23.09.26</a:t>
+              <a:t>27.09.26</a:t>
             </a:fld>
             <a:endParaRPr lang="fr-CH"/>
           </a:p>
@@ -2687,7 +2689,7 @@
           <a:p>
             <a:fld id="{556A8663-3A33-4D99-A0DD-CF9F1D707ADE}" type="datetimeFigureOut">
               <a:rPr lang="fr-CH" smtClean="0"/>
-              <a:t>23.09.26</a:t>
+              <a:t>27.09.26</a:t>
             </a:fld>
             <a:endParaRPr lang="fr-CH"/>
           </a:p>
@@ -2829,7 +2831,7 @@
           <a:p>
             <a:fld id="{556A8663-3A33-4D99-A0DD-CF9F1D707ADE}" type="datetimeFigureOut">
               <a:rPr lang="fr-CH" smtClean="0"/>
-              <a:t>23.09.26</a:t>
+              <a:t>27.09.26</a:t>
             </a:fld>
             <a:endParaRPr lang="fr-CH"/>
           </a:p>
@@ -2942,7 +2944,7 @@
           <a:p>
             <a:fld id="{556A8663-3A33-4D99-A0DD-CF9F1D707ADE}" type="datetimeFigureOut">
               <a:rPr lang="fr-CH" smtClean="0"/>
-              <a:t>23.09.26</a:t>
+              <a:t>27.09.26</a:t>
             </a:fld>
             <a:endParaRPr lang="fr-CH"/>
           </a:p>
@@ -3255,7 +3257,7 @@
           <a:p>
             <a:fld id="{556A8663-3A33-4D99-A0DD-CF9F1D707ADE}" type="datetimeFigureOut">
               <a:rPr lang="fr-CH" smtClean="0"/>
-              <a:t>23.09.26</a:t>
+              <a:t>27.09.26</a:t>
             </a:fld>
             <a:endParaRPr lang="fr-CH"/>
           </a:p>
@@ -3544,7 +3546,7 @@
           <a:p>
             <a:fld id="{556A8663-3A33-4D99-A0DD-CF9F1D707ADE}" type="datetimeFigureOut">
               <a:rPr lang="fr-CH" smtClean="0"/>
-              <a:t>23.09.26</a:t>
+              <a:t>27.09.26</a:t>
             </a:fld>
             <a:endParaRPr lang="fr-CH"/>
           </a:p>
@@ -3787,7 +3789,7 @@
           <a:p>
             <a:fld id="{556A8663-3A33-4D99-A0DD-CF9F1D707ADE}" type="datetimeFigureOut">
               <a:rPr lang="fr-CH" smtClean="0"/>
-              <a:t>23.09.26</a:t>
+              <a:t>27.09.26</a:t>
             </a:fld>
             <a:endParaRPr lang="fr-CH"/>
           </a:p>
@@ -7721,6 +7723,332 @@
 </p:sld>
 </file>
 
+<file path=ppt/slides/slide2.xml><?xml version="1.0" encoding="utf-8"?>
+<p:sld xmlns:a="http://schemas.openxmlformats.org/drawingml/2006/main" xmlns:r="http://schemas.openxmlformats.org/officeDocument/2006/relationships" xmlns:p="http://schemas.openxmlformats.org/presentationml/2006/main">
+  <p:cSld>
+    <p:spTree>
+      <p:nvGrpSpPr>
+        <p:cNvPr id="1" name=""/>
+        <p:cNvGrpSpPr/>
+        <p:nvPr/>
+      </p:nvGrpSpPr>
+      <p:grpSpPr>
+        <a:xfrm>
+          <a:off x="0" y="0"/>
+          <a:ext cx="0" cy="0"/>
+          <a:chOff x="0" y="0"/>
+          <a:chExt cx="0" cy="0"/>
+        </a:xfrm>
+      </p:grpSpPr>
+      <p:sp>
+        <p:nvSpPr>
+          <p:cNvPr id="2" name="Titre 1">
+            <a:extLst>
+              <a:ext uri="{FF2B5EF4-FFF2-40B4-BE49-F238E27FC236}">
+                <a16:creationId xmlns:a16="http://schemas.microsoft.com/office/drawing/2014/main" id="{D9C78D0D-7A63-7BC8-90CB-C9F03F883C62}"/>
+              </a:ext>
+            </a:extLst>
+          </p:cNvPr>
+          <p:cNvSpPr>
+            <a:spLocks noGrp="1"/>
+          </p:cNvSpPr>
+          <p:nvPr>
+            <p:ph type="title"/>
+          </p:nvPr>
+        </p:nvSpPr>
+        <p:spPr/>
+        <p:txBody>
+          <a:bodyPr/>
+          <a:lstStyle/>
+          <a:p>
+            <a:r>
+              <a:rPr lang="fr-FR" dirty="0" err="1"/>
+              <a:t>What</a:t>
+            </a:r>
+            <a:r>
+              <a:rPr lang="fr-FR" dirty="0"/>
+              <a:t> </a:t>
+            </a:r>
+            <a:r>
+              <a:rPr lang="fr-FR" dirty="0" err="1"/>
+              <a:t>is</a:t>
+            </a:r>
+            <a:r>
+              <a:rPr lang="fr-FR" dirty="0"/>
+              <a:t> </a:t>
+            </a:r>
+            <a:r>
+              <a:rPr lang="fr-FR" dirty="0" err="1"/>
+              <a:t>partitioning</a:t>
+            </a:r>
+            <a:r>
+              <a:rPr lang="fr-FR" dirty="0"/>
+              <a:t> and </a:t>
+            </a:r>
+            <a:r>
+              <a:rPr lang="fr-FR" dirty="0" err="1"/>
+              <a:t>why</a:t>
+            </a:r>
+            <a:r>
+              <a:rPr lang="fr-FR" dirty="0"/>
+              <a:t> use </a:t>
+            </a:r>
+            <a:r>
+              <a:rPr lang="fr-FR" dirty="0" err="1"/>
+              <a:t>it</a:t>
+            </a:r>
+            <a:endParaRPr lang="fr-FR" dirty="0"/>
+          </a:p>
+        </p:txBody>
+      </p:sp>
+      <p:sp>
+        <p:nvSpPr>
+          <p:cNvPr id="3" name="Espace réservé du contenu 2">
+            <a:extLst>
+              <a:ext uri="{FF2B5EF4-FFF2-40B4-BE49-F238E27FC236}">
+                <a16:creationId xmlns:a16="http://schemas.microsoft.com/office/drawing/2014/main" id="{DF295F83-3482-61AB-2735-2F7D7F5FA285}"/>
+              </a:ext>
+            </a:extLst>
+          </p:cNvPr>
+          <p:cNvSpPr>
+            <a:spLocks noGrp="1"/>
+          </p:cNvSpPr>
+          <p:nvPr>
+            <p:ph sz="quarter" idx="10"/>
+          </p:nvPr>
+        </p:nvSpPr>
+        <p:spPr/>
+        <p:txBody>
+          <a:bodyPr/>
+          <a:lstStyle/>
+          <a:p>
+            <a:r>
+              <a:rPr lang="fr-FR" dirty="0" err="1"/>
+              <a:t>Make</a:t>
+            </a:r>
+            <a:r>
+              <a:rPr lang="fr-FR" dirty="0"/>
+              <a:t> multiple </a:t>
+            </a:r>
+            <a:r>
+              <a:rPr lang="fr-FR" dirty="0" err="1"/>
+              <a:t>little</a:t>
+            </a:r>
+            <a:r>
+              <a:rPr lang="fr-FR" dirty="0"/>
+              <a:t> files out of a big file</a:t>
+            </a:r>
+          </a:p>
+          <a:p>
+            <a:r>
+              <a:rPr lang="fr-FR" dirty="0"/>
+              <a:t>A </a:t>
+            </a:r>
+            <a:r>
+              <a:rPr lang="fr-FR" dirty="0" err="1"/>
+              <a:t>selected</a:t>
+            </a:r>
+            <a:r>
+              <a:rPr lang="fr-FR" dirty="0"/>
+              <a:t> </a:t>
+            </a:r>
+            <a:r>
+              <a:rPr lang="fr-FR" dirty="0" err="1"/>
+              <a:t>Dataset</a:t>
+            </a:r>
+            <a:r>
+              <a:rPr lang="fr-FR" dirty="0"/>
+              <a:t> </a:t>
+            </a:r>
+            <a:r>
+              <a:rPr lang="fr-FR" dirty="0" err="1"/>
+              <a:t>column</a:t>
+            </a:r>
+            <a:r>
+              <a:rPr lang="fr-FR" dirty="0"/>
+              <a:t> </a:t>
+            </a:r>
+            <a:r>
+              <a:rPr lang="fr-CH" dirty="0" err="1"/>
+              <a:t>becomes</a:t>
+            </a:r>
+            <a:r>
+              <a:rPr lang="fr-CH" dirty="0"/>
+              <a:t> part of the file </a:t>
+            </a:r>
+            <a:r>
+              <a:rPr lang="fr-CH" dirty="0" err="1"/>
+              <a:t>path</a:t>
+            </a:r>
+            <a:endParaRPr lang="fr-CH" dirty="0"/>
+          </a:p>
+          <a:p>
+            <a:endParaRPr lang="fr-CH" dirty="0"/>
+          </a:p>
+          <a:p>
+            <a:r>
+              <a:rPr lang="fr-CH" dirty="0"/>
+              <a:t>Partition </a:t>
+            </a:r>
+            <a:r>
+              <a:rPr lang="fr-CH" dirty="0" err="1"/>
+              <a:t>pruning</a:t>
+            </a:r>
+            <a:r>
+              <a:rPr lang="fr-CH" dirty="0"/>
+              <a:t>: the engine can look at the </a:t>
+            </a:r>
+            <a:r>
+              <a:rPr lang="fr-CH" dirty="0" err="1"/>
+              <a:t>path</a:t>
+            </a:r>
+            <a:r>
+              <a:rPr lang="fr-CH" dirty="0"/>
+              <a:t> </a:t>
+            </a:r>
+            <a:r>
+              <a:rPr lang="fr-CH" dirty="0" err="1"/>
+              <a:t>instead</a:t>
+            </a:r>
+            <a:r>
+              <a:rPr lang="fr-CH" dirty="0"/>
+              <a:t> of the data to </a:t>
+            </a:r>
+            <a:r>
+              <a:rPr lang="fr-CH" dirty="0" err="1"/>
+              <a:t>decide</a:t>
+            </a:r>
+            <a:r>
+              <a:rPr lang="fr-CH" dirty="0"/>
+              <a:t> </a:t>
+            </a:r>
+            <a:r>
+              <a:rPr lang="fr-CH" dirty="0" err="1"/>
+              <a:t>what</a:t>
+            </a:r>
+            <a:r>
+              <a:rPr lang="fr-CH" dirty="0"/>
+              <a:t> to skip, and </a:t>
+            </a:r>
+            <a:r>
+              <a:rPr lang="fr-CH" dirty="0" err="1"/>
+              <a:t>only</a:t>
+            </a:r>
+            <a:r>
+              <a:rPr lang="fr-CH" dirty="0"/>
+              <a:t> use relevant files to the </a:t>
+            </a:r>
+            <a:r>
+              <a:rPr lang="fr-CH" dirty="0" err="1"/>
+              <a:t>request</a:t>
+            </a:r>
+            <a:r>
+              <a:rPr lang="fr-CH"/>
+              <a:t>.</a:t>
+            </a:r>
+            <a:endParaRPr lang="fr-FR" dirty="0"/>
+          </a:p>
+        </p:txBody>
+      </p:sp>
+    </p:spTree>
+    <p:extLst>
+      <p:ext uri="{BB962C8B-B14F-4D97-AF65-F5344CB8AC3E}">
+        <p14:creationId xmlns:p14="http://schemas.microsoft.com/office/powerpoint/2010/main" val="1638496385"/>
+      </p:ext>
+    </p:extLst>
+  </p:cSld>
+  <p:clrMapOvr>
+    <a:masterClrMapping/>
+  </p:clrMapOvr>
+  <p:transition>
+    <p:fade/>
+  </p:transition>
+</p:sld>
+</file>
+
+<file path=ppt/slides/slide3.xml><?xml version="1.0" encoding="utf-8"?>
+<p:sld xmlns:a="http://schemas.openxmlformats.org/drawingml/2006/main" xmlns:r="http://schemas.openxmlformats.org/officeDocument/2006/relationships" xmlns:p="http://schemas.openxmlformats.org/presentationml/2006/main">
+  <p:cSld>
+    <p:spTree>
+      <p:nvGrpSpPr>
+        <p:cNvPr id="1" name=""/>
+        <p:cNvGrpSpPr/>
+        <p:nvPr/>
+      </p:nvGrpSpPr>
+      <p:grpSpPr>
+        <a:xfrm>
+          <a:off x="0" y="0"/>
+          <a:ext cx="0" cy="0"/>
+          <a:chOff x="0" y="0"/>
+          <a:chExt cx="0" cy="0"/>
+        </a:xfrm>
+      </p:grpSpPr>
+      <p:sp>
+        <p:nvSpPr>
+          <p:cNvPr id="2" name="Titre 1">
+            <a:extLst>
+              <a:ext uri="{FF2B5EF4-FFF2-40B4-BE49-F238E27FC236}">
+                <a16:creationId xmlns:a16="http://schemas.microsoft.com/office/drawing/2014/main" id="{ED4F8155-D1C7-9DA5-626D-37835CF83BD3}"/>
+              </a:ext>
+            </a:extLst>
+          </p:cNvPr>
+          <p:cNvSpPr>
+            <a:spLocks noGrp="1"/>
+          </p:cNvSpPr>
+          <p:nvPr>
+            <p:ph type="title"/>
+          </p:nvPr>
+        </p:nvSpPr>
+        <p:spPr/>
+        <p:txBody>
+          <a:bodyPr/>
+          <a:lstStyle/>
+          <a:p>
+            <a:endParaRPr lang="fr-FR"/>
+          </a:p>
+        </p:txBody>
+      </p:sp>
+      <p:sp>
+        <p:nvSpPr>
+          <p:cNvPr id="3" name="Espace réservé du contenu 2">
+            <a:extLst>
+              <a:ext uri="{FF2B5EF4-FFF2-40B4-BE49-F238E27FC236}">
+                <a16:creationId xmlns:a16="http://schemas.microsoft.com/office/drawing/2014/main" id="{ABD6E226-FFD3-FBDF-4F46-E63C2C7ABE7E}"/>
+              </a:ext>
+            </a:extLst>
+          </p:cNvPr>
+          <p:cNvSpPr>
+            <a:spLocks noGrp="1"/>
+          </p:cNvSpPr>
+          <p:nvPr>
+            <p:ph sz="quarter" idx="10"/>
+          </p:nvPr>
+        </p:nvSpPr>
+        <p:spPr/>
+        <p:txBody>
+          <a:bodyPr/>
+          <a:lstStyle/>
+          <a:p>
+            <a:endParaRPr lang="fr-FR"/>
+          </a:p>
+        </p:txBody>
+      </p:sp>
+    </p:spTree>
+    <p:extLst>
+      <p:ext uri="{BB962C8B-B14F-4D97-AF65-F5344CB8AC3E}">
+        <p14:creationId xmlns:p14="http://schemas.microsoft.com/office/powerpoint/2010/main" val="1433872669"/>
+      </p:ext>
+    </p:extLst>
+  </p:cSld>
+  <p:clrMapOvr>
+    <a:masterClrMapping/>
+  </p:clrMapOvr>
+  <p:transition>
+    <p:fade/>
+  </p:transition>
+</p:sld>
+</file>
+
 <file path=ppt/theme/theme1.xml><?xml version="1.0" encoding="utf-8"?>
 <a:theme xmlns:a="http://schemas.openxmlformats.org/drawingml/2006/main" name="Thème Office">
   <a:themeElements>

</xml_diff>